<commit_message>
Update Week 12 Day 2 in-class flow
</commit_message>
<xml_diff>
--- a/week_12/day_2/week12_day2_dataset_sources_data_dictionary.pptx
+++ b/week_12/day_2/week12_day2_dataset_sources_data_dictionary.pptx
@@ -1098,7 +1098,7 @@
           </a:p>
           <a:p>
             <a:r>
-              <a:t>The homework is a short response to a relevant NYC Open Data video. The point is not to memorize the specific dataset. The point is to watch someone explore a public dataset and think about why structure matters. Students should write two short paragraphs and connect the video to their final project idea. The homework file includes the YouTube link and an MLA-style source entry to place at the end.</a:t>
+              <a:t>There is no homework for today. Instead, we are using the last part of class to finish the dataset lab and submit it before leaving. Students should make sure their document includes the dataset choice, a mini data dictionary for six to eight columns, security, privacy, or ethics concerns, and the short reflection. The goal is to leave class with a concrete final project artifact, not with another task to do later. If students finish early, they should use the extra time to improve their final project question or identify one source they still need.</a:t>
             </a:r>
           </a:p>
           <a:p/>
@@ -1109,17 +1109,22 @@
           </a:p>
           <a:p>
             <a:r>
-              <a:t>- Video: NYC OpenData Journey 005: Motor Vehicle Collisions.</a:t>
-            </a:r>
-          </a:p>
-          <a:p>
-            <a:r>
-              <a:t>- Homework length: 250 to 350 words.</a:t>
-            </a:r>
-          </a:p>
-          <a:p>
-            <a:r>
-              <a:t>- Connect to final project idea.</a:t>
+              <a:t>- No homework today.</a:t>
+            </a:r>
+          </a:p>
+          <a:p>
+            <a:r>
+              <a:t>- Submission happens before students leave.</a:t>
+            </a:r>
+          </a:p>
+          <a:p>
+            <a:r>
+              <a:t>- This finish block replaces the video response.</a:t>
+            </a:r>
+          </a:p>
+          <a:p>
+            <a:r>
+              <a:t>- Early finishers should improve their final project question or evidence plan.</a:t>
             </a:r>
           </a:p>
         </p:txBody>
@@ -1194,7 +1199,7 @@
           </a:p>
           <a:p>
             <a:r>
-              <a:t>The big takeaway from today is that responsible analysis begins before code and before argument. It begins with understanding the dataset. What does one row mean? What do the columns mean? Which values are missing or unclear? Which columns create security, privacy, or ethics concerns? If students can answer those questions, they are in a much better position to build a final project that is specific, careful, and connected to course concepts.</a:t>
+              <a:t>The big takeaway from today is that responsible analysis begins before code and before argument. It begins with understanding the dataset. What does one row mean? What do the columns mean? Which values are missing or unclear? Which columns create security, privacy, or ethics concerns? If students can answer those questions, they are in a much better position to build a final project that is specific, careful, and connected to course concepts. The final step today is to submit the dataset lab before leaving class.</a:t>
             </a:r>
           </a:p>
           <a:p/>
@@ -1210,12 +1215,12 @@
           </a:p>
           <a:p>
             <a:r>
-              <a:t>- Students should submit the Day 2 dataset lab.</a:t>
-            </a:r>
-          </a:p>
-          <a:p>
-            <a:r>
-              <a:t>- Homework is the video response.</a:t>
+              <a:t>- Students should submit the Day 2 dataset lab in class.</a:t>
+            </a:r>
+          </a:p>
+          <a:p>
+            <a:r>
+              <a:t>- There is no homework for this class meeting.</a:t>
             </a:r>
           </a:p>
         </p:txBody>
@@ -8657,16 +8662,8 @@
           <a:bodyPr rtlCol="0" anchor="ctr"/>
           <a:lstStyle/>
           <a:p>
-            <a:pPr algn="ctr">
-              <a:defRPr sz="1200" b="1">
-                <a:solidFill>
-                  <a:srgbClr val="186F79"/>
-                </a:solidFill>
-                <a:latin typeface="Aptos"/>
-              </a:defRPr>
-            </a:pPr>
-            <a:r>
-              <a:t>Homework</a:t>
+            <a:r>
+              <a:t>In-Class Finish</a:t>
             </a:r>
           </a:p>
         </p:txBody>
@@ -8693,16 +8690,8 @@
           </a:bodyPr>
           <a:lstStyle/>
           <a:p>
-            <a:pPr>
-              <a:defRPr sz="2200" b="1">
-                <a:solidFill>
-                  <a:srgbClr val="162635"/>
-                </a:solidFill>
-                <a:latin typeface="Aptos Display"/>
-              </a:defRPr>
-            </a:pPr>
-            <a:r>
-              <a:t>Video response: NYC OpenData Journey 005</a:t>
+            <a:r>
+              <a:t>Use the last block to complete and submit the dataset lab</a:t>
             </a:r>
           </a:p>
         </p:txBody>
@@ -8828,16 +8817,8 @@
           <a:bodyPr rtlCol="0" anchor="ctr"/>
           <a:lstStyle/>
           <a:p>
-            <a:pPr algn="ctr">
-              <a:defRPr sz="1200" b="1">
-                <a:solidFill>
-                  <a:srgbClr val="162635"/>
-                </a:solidFill>
-                <a:latin typeface="Aptos"/>
-              </a:defRPr>
-            </a:pPr>
-            <a:r>
-              <a:t>Watch</a:t>
+            <a:r>
+              <a:t>Finish</a:t>
             </a:r>
           </a:p>
         </p:txBody>
@@ -8864,51 +8845,18 @@
           </a:bodyPr>
           <a:lstStyle/>
           <a:p>
-            <a:pPr>
-              <a:spcAft>
-                <a:spcPts val="600"/>
-              </a:spcAft>
-              <a:defRPr sz="1700" b="0">
-                <a:solidFill>
-                  <a:srgbClr val="202B32"/>
-                </a:solidFill>
-                <a:latin typeface="Aptos"/>
-              </a:defRPr>
-            </a:pPr>
-            <a:r>
-              <a:t>NYC OpenData Journey 005</a:t>
-            </a:r>
-          </a:p>
-          <a:p>
-            <a:pPr>
-              <a:spcAft>
-                <a:spcPts val="600"/>
-              </a:spcAft>
-              <a:defRPr sz="1700" b="0">
-                <a:solidFill>
-                  <a:srgbClr val="202B32"/>
-                </a:solidFill>
-                <a:latin typeface="Aptos"/>
-              </a:defRPr>
-            </a:pPr>
-            <a:r>
-              <a:t>Motor Vehicle Collisions</a:t>
-            </a:r>
-          </a:p>
-          <a:p>
-            <a:pPr>
-              <a:spcAft>
-                <a:spcPts val="600"/>
-              </a:spcAft>
-              <a:defRPr sz="1700" b="0">
-                <a:solidFill>
-                  <a:srgbClr val="202B32"/>
-                </a:solidFill>
-                <a:latin typeface="Aptos"/>
-              </a:defRPr>
-            </a:pPr>
-            <a:r>
-              <a:t>YouTube link in homework file</a:t>
+            <a:r>
+              <a:t>dataset choice</a:t>
+            </a:r>
+          </a:p>
+          <a:p>
+            <a:r>
+              <a:t>6-8 column data dictionary</a:t>
+            </a:r>
+          </a:p>
+          <a:p>
+            <a:r>
+              <a:t>security/privacy/ethics concerns</a:t>
             </a:r>
           </a:p>
         </p:txBody>
@@ -8999,14 +8947,6 @@
           <a:bodyPr rtlCol="0" anchor="ctr"/>
           <a:lstStyle/>
           <a:p>
-            <a:pPr algn="ctr">
-              <a:defRPr sz="1200" b="1">
-                <a:solidFill>
-                  <a:srgbClr val="162635"/>
-                </a:solidFill>
-                <a:latin typeface="Aptos"/>
-              </a:defRPr>
-            </a:pPr>
             <a:r>
               <a:t>Write</a:t>
             </a:r>
@@ -9035,67 +8975,18 @@
           </a:bodyPr>
           <a:lstStyle/>
           <a:p>
-            <a:pPr>
-              <a:spcAft>
-                <a:spcPts val="600"/>
-              </a:spcAft>
-              <a:defRPr sz="1700" b="0">
-                <a:solidFill>
-                  <a:srgbClr val="202B32"/>
-                </a:solidFill>
-                <a:latin typeface="Aptos"/>
-              </a:defRPr>
-            </a:pPr>
-            <a:r>
-              <a:t>250-350 words</a:t>
-            </a:r>
-          </a:p>
-          <a:p>
-            <a:pPr>
-              <a:spcAft>
-                <a:spcPts val="600"/>
-              </a:spcAft>
-              <a:defRPr sz="1700" b="0">
-                <a:solidFill>
-                  <a:srgbClr val="202B32"/>
-                </a:solidFill>
-                <a:latin typeface="Aptos"/>
-              </a:defRPr>
-            </a:pPr>
-            <a:r>
-              <a:t>dataset structure</a:t>
-            </a:r>
-          </a:p>
-          <a:p>
-            <a:pPr>
-              <a:spcAft>
-                <a:spcPts val="600"/>
-              </a:spcAft>
-              <a:defRPr sz="1700" b="0">
-                <a:solidFill>
-                  <a:srgbClr val="202B32"/>
-                </a:solidFill>
-                <a:latin typeface="Aptos"/>
-              </a:defRPr>
-            </a:pPr>
-            <a:r>
-              <a:t>data dictionary</a:t>
-            </a:r>
-          </a:p>
-          <a:p>
-            <a:pPr>
-              <a:spcAft>
-                <a:spcPts val="600"/>
-              </a:spcAft>
-              <a:defRPr sz="1700" b="0">
-                <a:solidFill>
-                  <a:srgbClr val="202B32"/>
-                </a:solidFill>
-                <a:latin typeface="Aptos"/>
-              </a:defRPr>
-            </a:pPr>
-            <a:r>
-              <a:t>privacy or ethics concern</a:t>
+            <a:r>
+              <a:t>120-180 word reflection</a:t>
+            </a:r>
+          </a:p>
+          <a:p>
+            <a:r>
+              <a:t>what you understand better</a:t>
+            </a:r>
+          </a:p>
+          <a:p>
+            <a:r>
+              <a:t>one concern you noticed</a:t>
             </a:r>
           </a:p>
         </p:txBody>
@@ -9186,16 +9077,8 @@
           <a:bodyPr rtlCol="0" anchor="ctr"/>
           <a:lstStyle/>
           <a:p>
-            <a:pPr algn="ctr">
-              <a:defRPr sz="1200" b="1">
-                <a:solidFill>
-                  <a:srgbClr val="162635"/>
-                </a:solidFill>
-                <a:latin typeface="Aptos"/>
-              </a:defRPr>
-            </a:pPr>
-            <a:r>
-              <a:t>Connect</a:t>
+            <a:r>
+              <a:t>Submit</a:t>
             </a:r>
           </a:p>
         </p:txBody>
@@ -9222,51 +9105,18 @@
           </a:bodyPr>
           <a:lstStyle/>
           <a:p>
-            <a:pPr>
-              <a:spcAft>
-                <a:spcPts val="600"/>
-              </a:spcAft>
-              <a:defRPr sz="1700" b="0">
-                <a:solidFill>
-                  <a:srgbClr val="202B32"/>
-                </a:solidFill>
-                <a:latin typeface="Aptos"/>
-              </a:defRPr>
-            </a:pPr>
-            <a:r>
-              <a:t>one idea from video</a:t>
-            </a:r>
-          </a:p>
-          <a:p>
-            <a:pPr>
-              <a:spcAft>
-                <a:spcPts val="600"/>
-              </a:spcAft>
-              <a:defRPr sz="1700" b="0">
-                <a:solidFill>
-                  <a:srgbClr val="202B32"/>
-                </a:solidFill>
-                <a:latin typeface="Aptos"/>
-              </a:defRPr>
-            </a:pPr>
-            <a:r>
-              <a:t>one final project connection</a:t>
-            </a:r>
-          </a:p>
-          <a:p>
-            <a:pPr>
-              <a:spcAft>
-                <a:spcPts val="600"/>
-              </a:spcAft>
-              <a:defRPr sz="1700" b="0">
-                <a:solidFill>
-                  <a:srgbClr val="202B32"/>
-                </a:solidFill>
-                <a:latin typeface="Aptos"/>
-              </a:defRPr>
-            </a:pPr>
-            <a:r>
-              <a:t>MLA-style source entry</a:t>
+            <a:r>
+              <a:t>one document</a:t>
+            </a:r>
+          </a:p>
+          <a:p>
+            <a:r>
+              <a:t>before leaving class</a:t>
+            </a:r>
+          </a:p>
+          <a:p>
+            <a:r>
+              <a:t>no homework today</a:t>
             </a:r>
           </a:p>
         </p:txBody>

</xml_diff>